<commit_message>
Update notebook and figures
</commit_message>
<xml_diff>
--- a/images/New Microsoft PowerPoint Presentation.pptx
+++ b/images/New Microsoft PowerPoint Presentation.pptx
@@ -6,6 +6,9 @@
   </p:sldMasterIdLst>
   <p:sldIdLst>
     <p:sldId id="256" r:id="rId2"/>
+    <p:sldId id="257" r:id="rId3"/>
+    <p:sldId id="258" r:id="rId4"/>
+    <p:sldId id="259" r:id="rId5"/>
   </p:sldIdLst>
   <p:sldSz cx="12192000" cy="6858000"/>
   <p:notesSz cx="6858000" cy="9144000"/>
@@ -104,6 +107,11 @@
       </a:defRPr>
     </a:lvl9pPr>
   </p:defaultTextStyle>
+  <p:extLst>
+    <p:ext uri="{EFAFB233-063F-42B5-8137-9DF3F51BA10A}">
+      <p15:sldGuideLst xmlns:p15="http://schemas.microsoft.com/office/powerpoint/2012/main"/>
+    </p:ext>
+  </p:extLst>
 </p:presentation>
 </file>
 
@@ -256,7 +264,7 @@
           <a:p>
             <a:fld id="{00AFC433-50EC-496A-AB60-3E3406C32AED}" type="datetimeFigureOut">
               <a:rPr lang="LID4096" smtClean="0"/>
-              <a:t>11/23/2025</a:t>
+              <a:t>03/01/2026</a:t>
             </a:fld>
             <a:endParaRPr lang="LID4096"/>
           </a:p>
@@ -456,7 +464,7 @@
           <a:p>
             <a:fld id="{00AFC433-50EC-496A-AB60-3E3406C32AED}" type="datetimeFigureOut">
               <a:rPr lang="LID4096" smtClean="0"/>
-              <a:t>11/23/2025</a:t>
+              <a:t>03/01/2026</a:t>
             </a:fld>
             <a:endParaRPr lang="LID4096"/>
           </a:p>
@@ -666,7 +674,7 @@
           <a:p>
             <a:fld id="{00AFC433-50EC-496A-AB60-3E3406C32AED}" type="datetimeFigureOut">
               <a:rPr lang="LID4096" smtClean="0"/>
-              <a:t>11/23/2025</a:t>
+              <a:t>03/01/2026</a:t>
             </a:fld>
             <a:endParaRPr lang="LID4096"/>
           </a:p>
@@ -866,7 +874,7 @@
           <a:p>
             <a:fld id="{00AFC433-50EC-496A-AB60-3E3406C32AED}" type="datetimeFigureOut">
               <a:rPr lang="LID4096" smtClean="0"/>
-              <a:t>11/23/2025</a:t>
+              <a:t>03/01/2026</a:t>
             </a:fld>
             <a:endParaRPr lang="LID4096"/>
           </a:p>
@@ -1142,7 +1150,7 @@
           <a:p>
             <a:fld id="{00AFC433-50EC-496A-AB60-3E3406C32AED}" type="datetimeFigureOut">
               <a:rPr lang="LID4096" smtClean="0"/>
-              <a:t>11/23/2025</a:t>
+              <a:t>03/01/2026</a:t>
             </a:fld>
             <a:endParaRPr lang="LID4096"/>
           </a:p>
@@ -1410,7 +1418,7 @@
           <a:p>
             <a:fld id="{00AFC433-50EC-496A-AB60-3E3406C32AED}" type="datetimeFigureOut">
               <a:rPr lang="LID4096" smtClean="0"/>
-              <a:t>11/23/2025</a:t>
+              <a:t>03/01/2026</a:t>
             </a:fld>
             <a:endParaRPr lang="LID4096"/>
           </a:p>
@@ -1825,7 +1833,7 @@
           <a:p>
             <a:fld id="{00AFC433-50EC-496A-AB60-3E3406C32AED}" type="datetimeFigureOut">
               <a:rPr lang="LID4096" smtClean="0"/>
-              <a:t>11/23/2025</a:t>
+              <a:t>03/01/2026</a:t>
             </a:fld>
             <a:endParaRPr lang="LID4096"/>
           </a:p>
@@ -1967,7 +1975,7 @@
           <a:p>
             <a:fld id="{00AFC433-50EC-496A-AB60-3E3406C32AED}" type="datetimeFigureOut">
               <a:rPr lang="LID4096" smtClean="0"/>
-              <a:t>11/23/2025</a:t>
+              <a:t>03/01/2026</a:t>
             </a:fld>
             <a:endParaRPr lang="LID4096"/>
           </a:p>
@@ -2080,7 +2088,7 @@
           <a:p>
             <a:fld id="{00AFC433-50EC-496A-AB60-3E3406C32AED}" type="datetimeFigureOut">
               <a:rPr lang="LID4096" smtClean="0"/>
-              <a:t>11/23/2025</a:t>
+              <a:t>03/01/2026</a:t>
             </a:fld>
             <a:endParaRPr lang="LID4096"/>
           </a:p>
@@ -2393,7 +2401,7 @@
           <a:p>
             <a:fld id="{00AFC433-50EC-496A-AB60-3E3406C32AED}" type="datetimeFigureOut">
               <a:rPr lang="LID4096" smtClean="0"/>
-              <a:t>11/23/2025</a:t>
+              <a:t>03/01/2026</a:t>
             </a:fld>
             <a:endParaRPr lang="LID4096"/>
           </a:p>
@@ -2682,7 +2690,7 @@
           <a:p>
             <a:fld id="{00AFC433-50EC-496A-AB60-3E3406C32AED}" type="datetimeFigureOut">
               <a:rPr lang="LID4096" smtClean="0"/>
-              <a:t>11/23/2025</a:t>
+              <a:t>03/01/2026</a:t>
             </a:fld>
             <a:endParaRPr lang="LID4096"/>
           </a:p>
@@ -2925,7 +2933,7 @@
           <a:p>
             <a:fld id="{00AFC433-50EC-496A-AB60-3E3406C32AED}" type="datetimeFigureOut">
               <a:rPr lang="LID4096" smtClean="0"/>
-              <a:t>11/23/2025</a:t>
+              <a:t>03/01/2026</a:t>
             </a:fld>
             <a:endParaRPr lang="LID4096"/>
           </a:p>
@@ -3356,7 +3364,7 @@
         </p:nvGrpSpPr>
         <p:grpSpPr>
           <a:xfrm>
-            <a:off x="1403509" y="57151"/>
+            <a:off x="1270159" y="387351"/>
             <a:ext cx="3749040" cy="5708983"/>
             <a:chOff x="1403509" y="57151"/>
             <a:chExt cx="3749040" cy="5708983"/>
@@ -3435,10 +3443,562 @@
           </p:spPr>
         </p:pic>
       </p:grpSp>
+      <p:pic>
+        <p:nvPicPr>
+          <p:cNvPr id="3" name="Picture 2">
+            <a:extLst>
+              <a:ext uri="{FF2B5EF4-FFF2-40B4-BE49-F238E27FC236}">
+                <a16:creationId xmlns:a16="http://schemas.microsoft.com/office/drawing/2014/main" id="{2775DB4A-7AE1-FF4B-33AD-21A27D04E65C}"/>
+              </a:ext>
+            </a:extLst>
+          </p:cNvPr>
+          <p:cNvPicPr>
+            <a:picLocks noChangeAspect="1"/>
+          </p:cNvPicPr>
+          <p:nvPr/>
+        </p:nvPicPr>
+        <p:blipFill>
+          <a:blip r:embed="rId4">
+            <a:extLst>
+              <a:ext uri="{28A0092B-C50C-407E-A947-70E740481C1C}">
+                <a14:useLocalDpi xmlns:a14="http://schemas.microsoft.com/office/drawing/2010/main" val="0"/>
+              </a:ext>
+            </a:extLst>
+          </a:blip>
+          <a:srcRect r="37738"/>
+          <a:stretch>
+            <a:fillRect/>
+          </a:stretch>
+        </p:blipFill>
+        <p:spPr>
+          <a:xfrm>
+            <a:off x="6517189" y="-266701"/>
+            <a:ext cx="5674811" cy="6858000"/>
+          </a:xfrm>
+          <a:prstGeom prst="rect">
+            <a:avLst/>
+          </a:prstGeom>
+        </p:spPr>
+      </p:pic>
     </p:spTree>
     <p:extLst>
       <p:ext uri="{BB962C8B-B14F-4D97-AF65-F5344CB8AC3E}">
         <p14:creationId xmlns:p14="http://schemas.microsoft.com/office/powerpoint/2010/main" val="1631861540"/>
+      </p:ext>
+    </p:extLst>
+  </p:cSld>
+  <p:clrMapOvr>
+    <a:masterClrMapping/>
+  </p:clrMapOvr>
+</p:sld>
+</file>
+
+<file path=ppt/slides/slide2.xml><?xml version="1.0" encoding="utf-8"?>
+<p:sld xmlns:a="http://schemas.openxmlformats.org/drawingml/2006/main" xmlns:r="http://schemas.openxmlformats.org/officeDocument/2006/relationships" xmlns:p="http://schemas.openxmlformats.org/presentationml/2006/main">
+  <p:cSld>
+    <p:spTree>
+      <p:nvGrpSpPr>
+        <p:cNvPr id="1" name=""/>
+        <p:cNvGrpSpPr/>
+        <p:nvPr/>
+      </p:nvGrpSpPr>
+      <p:grpSpPr>
+        <a:xfrm>
+          <a:off x="0" y="0"/>
+          <a:ext cx="0" cy="0"/>
+          <a:chOff x="0" y="0"/>
+          <a:chExt cx="0" cy="0"/>
+        </a:xfrm>
+      </p:grpSpPr>
+      <p:pic>
+        <p:nvPicPr>
+          <p:cNvPr id="5" name="Picture 4">
+            <a:extLst>
+              <a:ext uri="{FF2B5EF4-FFF2-40B4-BE49-F238E27FC236}">
+                <a16:creationId xmlns:a16="http://schemas.microsoft.com/office/drawing/2014/main" id="{02ED3C6E-3B7D-A4EF-AC15-714AFBBA25FF}"/>
+              </a:ext>
+            </a:extLst>
+          </p:cNvPr>
+          <p:cNvPicPr>
+            <a:picLocks noChangeAspect="1"/>
+          </p:cNvPicPr>
+          <p:nvPr/>
+        </p:nvPicPr>
+        <p:blipFill>
+          <a:blip r:embed="rId2">
+            <a:extLst>
+              <a:ext uri="{BEBA8EAE-BF5A-486C-A8C5-ECC9F3942E4B}">
+                <a14:imgProps xmlns:a14="http://schemas.microsoft.com/office/drawing/2010/main">
+                  <a14:imgLayer r:embed="rId3">
+                    <a14:imgEffect>
+                      <a14:backgroundRemoval t="4892" b="84149" l="41181" r="93670">
+                        <a14:foregroundMark x1="68137" y1="84149" x2="68137" y2="84149"/>
+                        <a14:foregroundMark x1="69061" y1="6360" x2="69061" y2="6360"/>
+                        <a14:foregroundMark x1="93670" y1="19863" x2="93670" y2="19863"/>
+                        <a14:foregroundMark x1="92461" y1="43738" x2="92461" y2="43738"/>
+                        <a14:foregroundMark x1="90754" y1="60959" x2="90754" y2="60959"/>
+                        <a14:foregroundMark x1="69844" y1="71331" x2="69844" y2="71331"/>
+                        <a14:foregroundMark x1="71977" y1="56458" x2="72191" y2="56458"/>
+                        <a14:foregroundMark x1="80868" y1="51272" x2="81152" y2="51272"/>
+                        <a14:foregroundMark x1="67141" y1="44325" x2="66714" y2="44325"/>
+                        <a14:foregroundMark x1="55974" y1="42955" x2="54765" y2="44031"/>
+                        <a14:foregroundMark x1="49147" y1="44716" x2="49147" y2="47162"/>
+                        <a14:foregroundMark x1="48222" y1="50098" x2="48080" y2="51957"/>
+                        <a14:foregroundMark x1="46657" y1="54110" x2="46657" y2="54892"/>
+                        <a14:foregroundMark x1="45448" y1="46282" x2="45448" y2="46282"/>
+                        <a14:foregroundMark x1="43030" y1="37084" x2="43030" y2="37084"/>
+                        <a14:foregroundMark x1="42319" y1="32681" x2="42319" y2="32681"/>
+                        <a14:foregroundMark x1="41181" y1="21526" x2="41181" y2="21526"/>
+                        <a14:foregroundMark x1="68706" y1="4892" x2="68706" y2="4892"/>
+                        <a14:foregroundMark x1="66999" y1="38748" x2="66999" y2="38748"/>
+                      </a14:backgroundRemoval>
+                    </a14:imgEffect>
+                  </a14:imgLayer>
+                </a14:imgProps>
+              </a:ext>
+              <a:ext uri="{28A0092B-C50C-407E-A947-70E740481C1C}">
+                <a14:useLocalDpi xmlns:a14="http://schemas.microsoft.com/office/drawing/2010/main" val="0"/>
+              </a:ext>
+            </a:extLst>
+          </a:blip>
+          <a:srcRect l="35126" b="8704"/>
+          <a:stretch>
+            <a:fillRect/>
+          </a:stretch>
+        </p:blipFill>
+        <p:spPr>
+          <a:xfrm>
+            <a:off x="-24741" y="247650"/>
+            <a:ext cx="6120741" cy="6261100"/>
+          </a:xfrm>
+          <a:prstGeom prst="rect">
+            <a:avLst/>
+          </a:prstGeom>
+        </p:spPr>
+      </p:pic>
+      <p:pic>
+        <p:nvPicPr>
+          <p:cNvPr id="7" name="Picture 6">
+            <a:extLst>
+              <a:ext uri="{FF2B5EF4-FFF2-40B4-BE49-F238E27FC236}">
+                <a16:creationId xmlns:a16="http://schemas.microsoft.com/office/drawing/2014/main" id="{B6B862EC-564E-BFD5-D2A4-E4FD70858160}"/>
+              </a:ext>
+            </a:extLst>
+          </p:cNvPr>
+          <p:cNvPicPr>
+            <a:picLocks noChangeAspect="1"/>
+          </p:cNvPicPr>
+          <p:nvPr/>
+        </p:nvPicPr>
+        <p:blipFill>
+          <a:blip r:embed="rId4">
+            <a:extLst>
+              <a:ext uri="{28A0092B-C50C-407E-A947-70E740481C1C}">
+                <a14:useLocalDpi xmlns:a14="http://schemas.microsoft.com/office/drawing/2010/main" val="0"/>
+              </a:ext>
+            </a:extLst>
+          </a:blip>
+          <a:srcRect l="36903" b="8704"/>
+          <a:stretch>
+            <a:fillRect/>
+          </a:stretch>
+        </p:blipFill>
+        <p:spPr>
+          <a:xfrm>
+            <a:off x="4033047" y="247650"/>
+            <a:ext cx="6120742" cy="6261100"/>
+          </a:xfrm>
+          <a:prstGeom prst="rect">
+            <a:avLst/>
+          </a:prstGeom>
+        </p:spPr>
+      </p:pic>
+      <p:pic>
+        <p:nvPicPr>
+          <p:cNvPr id="9" name="Picture 8">
+            <a:extLst>
+              <a:ext uri="{FF2B5EF4-FFF2-40B4-BE49-F238E27FC236}">
+                <a16:creationId xmlns:a16="http://schemas.microsoft.com/office/drawing/2014/main" id="{E5ABE9F1-EBC4-B5FB-1F09-1D591F214947}"/>
+              </a:ext>
+            </a:extLst>
+          </p:cNvPr>
+          <p:cNvPicPr>
+            <a:picLocks noChangeAspect="1"/>
+          </p:cNvPicPr>
+          <p:nvPr/>
+        </p:nvPicPr>
+        <p:blipFill>
+          <a:blip r:embed="rId5">
+            <a:extLst>
+              <a:ext uri="{28A0092B-C50C-407E-A947-70E740481C1C}">
+                <a14:useLocalDpi xmlns:a14="http://schemas.microsoft.com/office/drawing/2010/main" val="0"/>
+              </a:ext>
+            </a:extLst>
+          </a:blip>
+          <a:srcRect l="44196" t="-833" r="-1" b="9536"/>
+          <a:stretch>
+            <a:fillRect/>
+          </a:stretch>
+        </p:blipFill>
+        <p:spPr>
+          <a:xfrm>
+            <a:off x="6705600" y="-74809"/>
+            <a:ext cx="5486400" cy="6583559"/>
+          </a:xfrm>
+          <a:prstGeom prst="rect">
+            <a:avLst/>
+          </a:prstGeom>
+        </p:spPr>
+      </p:pic>
+    </p:spTree>
+    <p:extLst>
+      <p:ext uri="{BB962C8B-B14F-4D97-AF65-F5344CB8AC3E}">
+        <p14:creationId xmlns:p14="http://schemas.microsoft.com/office/powerpoint/2010/main" val="1597039375"/>
+      </p:ext>
+    </p:extLst>
+  </p:cSld>
+  <p:clrMapOvr>
+    <a:masterClrMapping/>
+  </p:clrMapOvr>
+</p:sld>
+</file>
+
+<file path=ppt/slides/slide3.xml><?xml version="1.0" encoding="utf-8"?>
+<p:sld xmlns:a="http://schemas.openxmlformats.org/drawingml/2006/main" xmlns:r="http://schemas.openxmlformats.org/officeDocument/2006/relationships" xmlns:p="http://schemas.openxmlformats.org/presentationml/2006/main">
+  <p:cSld>
+    <p:spTree>
+      <p:nvGrpSpPr>
+        <p:cNvPr id="1" name=""/>
+        <p:cNvGrpSpPr/>
+        <p:nvPr/>
+      </p:nvGrpSpPr>
+      <p:grpSpPr>
+        <a:xfrm>
+          <a:off x="0" y="0"/>
+          <a:ext cx="0" cy="0"/>
+          <a:chOff x="0" y="0"/>
+          <a:chExt cx="0" cy="0"/>
+        </a:xfrm>
+      </p:grpSpPr>
+      <p:pic>
+        <p:nvPicPr>
+          <p:cNvPr id="5" name="Picture 4">
+            <a:extLst>
+              <a:ext uri="{FF2B5EF4-FFF2-40B4-BE49-F238E27FC236}">
+                <a16:creationId xmlns:a16="http://schemas.microsoft.com/office/drawing/2014/main" id="{A22522C5-0AE6-8F28-887E-64895D67BDB4}"/>
+              </a:ext>
+            </a:extLst>
+          </p:cNvPr>
+          <p:cNvPicPr>
+            <a:picLocks noChangeAspect="1"/>
+          </p:cNvPicPr>
+          <p:nvPr/>
+        </p:nvPicPr>
+        <p:blipFill>
+          <a:blip r:embed="rId2">
+            <a:extLst>
+              <a:ext uri="{28A0092B-C50C-407E-A947-70E740481C1C}">
+                <a14:useLocalDpi xmlns:a14="http://schemas.microsoft.com/office/drawing/2010/main" val="0"/>
+              </a:ext>
+            </a:extLst>
+          </a:blip>
+          <a:srcRect l="52253" t="2778" b="7361"/>
+          <a:stretch>
+            <a:fillRect/>
+          </a:stretch>
+        </p:blipFill>
+        <p:spPr>
+          <a:xfrm>
+            <a:off x="0" y="347659"/>
+            <a:ext cx="4239115" cy="6162675"/>
+          </a:xfrm>
+          <a:prstGeom prst="rect">
+            <a:avLst/>
+          </a:prstGeom>
+        </p:spPr>
+      </p:pic>
+      <p:pic>
+        <p:nvPicPr>
+          <p:cNvPr id="6" name="Picture 5">
+            <a:extLst>
+              <a:ext uri="{FF2B5EF4-FFF2-40B4-BE49-F238E27FC236}">
+                <a16:creationId xmlns:a16="http://schemas.microsoft.com/office/drawing/2014/main" id="{D21F5E06-B237-1AC3-1280-827F2044D167}"/>
+              </a:ext>
+            </a:extLst>
+          </p:cNvPr>
+          <p:cNvPicPr>
+            <a:picLocks noChangeAspect="1"/>
+          </p:cNvPicPr>
+          <p:nvPr/>
+        </p:nvPicPr>
+        <p:blipFill>
+          <a:blip r:embed="rId3">
+            <a:extLst>
+              <a:ext uri="{BEBA8EAE-BF5A-486C-A8C5-ECC9F3942E4B}">
+                <a14:imgProps xmlns:a14="http://schemas.microsoft.com/office/drawing/2010/main">
+                  <a14:imgLayer r:embed="rId4">
+                    <a14:imgEffect>
+                      <a14:backgroundRemoval t="4892" b="84149" l="41181" r="93670">
+                        <a14:foregroundMark x1="68137" y1="84149" x2="68137" y2="84149"/>
+                        <a14:foregroundMark x1="69061" y1="6360" x2="69061" y2="6360"/>
+                        <a14:foregroundMark x1="93670" y1="19863" x2="93670" y2="19863"/>
+                        <a14:foregroundMark x1="92461" y1="43738" x2="92461" y2="43738"/>
+                        <a14:foregroundMark x1="90754" y1="60959" x2="90754" y2="60959"/>
+                        <a14:foregroundMark x1="69844" y1="71331" x2="69844" y2="71331"/>
+                        <a14:foregroundMark x1="71977" y1="56458" x2="72191" y2="56458"/>
+                        <a14:foregroundMark x1="80868" y1="51272" x2="81152" y2="51272"/>
+                        <a14:foregroundMark x1="67141" y1="44325" x2="66714" y2="44325"/>
+                        <a14:foregroundMark x1="55974" y1="42955" x2="54765" y2="44031"/>
+                        <a14:foregroundMark x1="49147" y1="44716" x2="49147" y2="47162"/>
+                        <a14:foregroundMark x1="48222" y1="50098" x2="48080" y2="51957"/>
+                        <a14:foregroundMark x1="46657" y1="54110" x2="46657" y2="54892"/>
+                        <a14:foregroundMark x1="45448" y1="46282" x2="45448" y2="46282"/>
+                        <a14:foregroundMark x1="43030" y1="37084" x2="43030" y2="37084"/>
+                        <a14:foregroundMark x1="42319" y1="32681" x2="42319" y2="32681"/>
+                        <a14:foregroundMark x1="41181" y1="21526" x2="41181" y2="21526"/>
+                        <a14:foregroundMark x1="68706" y1="4892" x2="68706" y2="4892"/>
+                        <a14:foregroundMark x1="66999" y1="38748" x2="66999" y2="38748"/>
+                      </a14:backgroundRemoval>
+                    </a14:imgEffect>
+                  </a14:imgLayer>
+                </a14:imgProps>
+              </a:ext>
+              <a:ext uri="{28A0092B-C50C-407E-A947-70E740481C1C}">
+                <a14:useLocalDpi xmlns:a14="http://schemas.microsoft.com/office/drawing/2010/main" val="0"/>
+              </a:ext>
+            </a:extLst>
+          </a:blip>
+          <a:srcRect l="35126" b="8704"/>
+          <a:stretch>
+            <a:fillRect/>
+          </a:stretch>
+        </p:blipFill>
+        <p:spPr>
+          <a:xfrm>
+            <a:off x="4029075" y="1149034"/>
+            <a:ext cx="4457700" cy="4559923"/>
+          </a:xfrm>
+          <a:prstGeom prst="rect">
+            <a:avLst/>
+          </a:prstGeom>
+        </p:spPr>
+      </p:pic>
+      <p:pic>
+        <p:nvPicPr>
+          <p:cNvPr id="8" name="Picture 7">
+            <a:extLst>
+              <a:ext uri="{FF2B5EF4-FFF2-40B4-BE49-F238E27FC236}">
+                <a16:creationId xmlns:a16="http://schemas.microsoft.com/office/drawing/2014/main" id="{4B1C53A2-F7E5-E32A-F74C-F5681F0417FC}"/>
+              </a:ext>
+            </a:extLst>
+          </p:cNvPr>
+          <p:cNvPicPr>
+            <a:picLocks noChangeAspect="1"/>
+          </p:cNvPicPr>
+          <p:nvPr/>
+        </p:nvPicPr>
+        <p:blipFill>
+          <a:blip r:embed="rId5">
+            <a:extLst>
+              <a:ext uri="{28A0092B-C50C-407E-A947-70E740481C1C}">
+                <a14:useLocalDpi xmlns:a14="http://schemas.microsoft.com/office/drawing/2010/main" val="0"/>
+              </a:ext>
+            </a:extLst>
+          </a:blip>
+          <a:srcRect l="28746" t="7083" r="36816" b="13194"/>
+          <a:stretch>
+            <a:fillRect/>
+          </a:stretch>
+        </p:blipFill>
+        <p:spPr>
+          <a:xfrm>
+            <a:off x="7086600" y="495300"/>
+            <a:ext cx="4105275" cy="5467350"/>
+          </a:xfrm>
+          <a:prstGeom prst="rect">
+            <a:avLst/>
+          </a:prstGeom>
+        </p:spPr>
+      </p:pic>
+    </p:spTree>
+    <p:extLst>
+      <p:ext uri="{BB962C8B-B14F-4D97-AF65-F5344CB8AC3E}">
+        <p14:creationId xmlns:p14="http://schemas.microsoft.com/office/powerpoint/2010/main" val="4127060531"/>
+      </p:ext>
+    </p:extLst>
+  </p:cSld>
+  <p:clrMapOvr>
+    <a:masterClrMapping/>
+  </p:clrMapOvr>
+</p:sld>
+</file>
+
+<file path=ppt/slides/slide4.xml><?xml version="1.0" encoding="utf-8"?>
+<p:sld xmlns:a="http://schemas.openxmlformats.org/drawingml/2006/main" xmlns:r="http://schemas.openxmlformats.org/officeDocument/2006/relationships" xmlns:p="http://schemas.openxmlformats.org/presentationml/2006/main">
+  <p:cSld>
+    <p:spTree>
+      <p:nvGrpSpPr>
+        <p:cNvPr id="1" name=""/>
+        <p:cNvGrpSpPr/>
+        <p:nvPr/>
+      </p:nvGrpSpPr>
+      <p:grpSpPr>
+        <a:xfrm>
+          <a:off x="0" y="0"/>
+          <a:ext cx="0" cy="0"/>
+          <a:chOff x="0" y="0"/>
+          <a:chExt cx="0" cy="0"/>
+        </a:xfrm>
+      </p:grpSpPr>
+      <p:pic>
+        <p:nvPicPr>
+          <p:cNvPr id="1026" name="Picture 2" descr="models/grace-1l-oam • Matbench Discovery">
+            <a:extLst>
+              <a:ext uri="{FF2B5EF4-FFF2-40B4-BE49-F238E27FC236}">
+                <a16:creationId xmlns:a16="http://schemas.microsoft.com/office/drawing/2014/main" id="{6B00EB73-B0D8-ABE5-06ED-FB49EE10292C}"/>
+              </a:ext>
+            </a:extLst>
+          </p:cNvPr>
+          <p:cNvPicPr>
+            <a:picLocks noChangeAspect="1" noChangeArrowheads="1"/>
+          </p:cNvPicPr>
+          <p:nvPr/>
+        </p:nvPicPr>
+        <p:blipFill>
+          <a:blip r:embed="rId2">
+            <a:extLst>
+              <a:ext uri="{28A0092B-C50C-407E-A947-70E740481C1C}">
+                <a14:useLocalDpi xmlns:a14="http://schemas.microsoft.com/office/drawing/2010/main" val="0"/>
+              </a:ext>
+            </a:extLst>
+          </a:blip>
+          <a:srcRect/>
+          <a:stretch>
+            <a:fillRect/>
+          </a:stretch>
+        </p:blipFill>
+        <p:spPr bwMode="auto">
+          <a:xfrm>
+            <a:off x="4289425" y="2095500"/>
+            <a:ext cx="4152900" cy="1104900"/>
+          </a:xfrm>
+          <a:prstGeom prst="rect">
+            <a:avLst/>
+          </a:prstGeom>
+          <a:noFill/>
+          <a:extLst>
+            <a:ext uri="{909E8E84-426E-40DD-AFC4-6F175D3DCCD1}">
+              <a14:hiddenFill xmlns:a14="http://schemas.microsoft.com/office/drawing/2010/main">
+                <a:solidFill>
+                  <a:srgbClr val="FFFFFF"/>
+                </a:solidFill>
+              </a14:hiddenFill>
+            </a:ext>
+          </a:extLst>
+        </p:spPr>
+      </p:pic>
+      <p:pic>
+        <p:nvPicPr>
+          <p:cNvPr id="3" name="Picture 2">
+            <a:extLst>
+              <a:ext uri="{FF2B5EF4-FFF2-40B4-BE49-F238E27FC236}">
+                <a16:creationId xmlns:a16="http://schemas.microsoft.com/office/drawing/2014/main" id="{79D82050-BD5E-5040-8E0D-E3DCECD75A55}"/>
+              </a:ext>
+            </a:extLst>
+          </p:cNvPr>
+          <p:cNvPicPr>
+            <a:picLocks noChangeAspect="1"/>
+          </p:cNvPicPr>
+          <p:nvPr/>
+        </p:nvPicPr>
+        <p:blipFill>
+          <a:blip r:embed="rId3">
+            <a:extLst>
+              <a:ext uri="{BEBA8EAE-BF5A-486C-A8C5-ECC9F3942E4B}">
+                <a14:imgProps xmlns:a14="http://schemas.microsoft.com/office/drawing/2010/main">
+                  <a14:imgLayer r:embed="rId4">
+                    <a14:imgEffect>
+                      <a14:backgroundRemoval t="9943" b="89675" l="5957" r="89844">
+                        <a14:foregroundMark x1="14258" y1="18164" x2="14258" y2="18164"/>
+                        <a14:foregroundMark x1="15137" y1="16826" x2="15137" y2="16826"/>
+                        <a14:foregroundMark x1="16211" y1="15296" x2="16211" y2="15296"/>
+                        <a14:foregroundMark x1="17285" y1="14532" x2="17285" y2="14532"/>
+                        <a14:foregroundMark x1="8984" y1="29828" x2="8984" y2="29828"/>
+                        <a14:foregroundMark x1="23340" y1="83556" x2="23340" y2="83556"/>
+                        <a14:foregroundMark x1="18848" y1="87380" x2="18848" y2="87380"/>
+                        <a14:foregroundMark x1="16699" y1="85468" x2="16699" y2="85468"/>
+                        <a14:foregroundMark x1="49902" y1="57935" x2="49902" y2="57935"/>
+                        <a14:foregroundMark x1="54590" y1="55258" x2="54590" y2="55258"/>
+                        <a14:foregroundMark x1="68164" y1="52008" x2="68164" y2="52008"/>
+                        <a14:foregroundMark x1="75098" y1="53728" x2="75098" y2="53728"/>
+                        <a14:foregroundMark x1="84961" y1="53155" x2="84961" y2="53155"/>
+                        <a14:foregroundMark x1="41699" y1="50096" x2="41699" y2="50096"/>
+                        <a14:foregroundMark x1="37305" y1="26004" x2="37305" y2="26004"/>
+                        <a14:foregroundMark x1="32520" y1="16826" x2="32520" y2="16826"/>
+                        <a14:foregroundMark x1="30078" y1="14340" x2="30078" y2="14340"/>
+                        <a14:foregroundMark x1="32520" y1="11090" x2="32520" y2="11090"/>
+                        <a14:foregroundMark x1="36230" y1="11281" x2="36230" y2="11281"/>
+                        <a14:foregroundMark x1="41602" y1="18356" x2="41602" y2="18356"/>
+                        <a14:foregroundMark x1="41797" y1="28489" x2="41797" y2="28489"/>
+                        <a14:foregroundMark x1="41699" y1="37094" x2="41699" y2="37094"/>
+                        <a14:foregroundMark x1="41699" y1="62906" x2="41699" y2="62906"/>
+                        <a14:foregroundMark x1="41699" y1="71128" x2="41699" y2="71128"/>
+                        <a14:foregroundMark x1="41602" y1="81071" x2="41602" y2="81071"/>
+                        <a14:foregroundMark x1="41699" y1="88337" x2="41699" y2="88337"/>
+                        <a14:foregroundMark x1="36133" y1="89101" x2="36133" y2="89101"/>
+                        <a14:foregroundMark x1="31641" y1="89293" x2="31641" y2="89293"/>
+                        <a14:foregroundMark x1="5957" y1="51434" x2="5957" y2="51434"/>
+                        <a14:foregroundMark x1="16406" y1="15488" x2="16406" y2="15488"/>
+                        <a14:foregroundMark x1="28418" y1="11281" x2="28418" y2="11281"/>
+                        <a14:foregroundMark x1="29102" y1="13193" x2="29102" y2="13193"/>
+                        <a14:foregroundMark x1="31445" y1="15488" x2="31445" y2="15488"/>
+                        <a14:foregroundMark x1="30566" y1="85660" x2="30566" y2="85660"/>
+                        <a14:foregroundMark x1="31738" y1="84321" x2="31738" y2="84321"/>
+                        <a14:foregroundMark x1="28613" y1="87380" x2="28613" y2="87380"/>
+                        <a14:foregroundMark x1="37305" y1="74761" x2="37305" y2="74761"/>
+                        <a14:foregroundMark x1="38379" y1="71319" x2="38379" y2="71319"/>
+                        <a14:foregroundMark x1="39355" y1="68069" x2="39355" y2="68069"/>
+                        <a14:foregroundMark x1="39941" y1="65392" x2="39941" y2="65392"/>
+                        <a14:foregroundMark x1="35449" y1="50287" x2="35449" y2="50287"/>
+                        <a14:foregroundMark x1="32031" y1="50096" x2="32031" y2="50096"/>
+                        <a14:foregroundMark x1="27246" y1="50287" x2="27246" y2="50287"/>
+                        <a14:foregroundMark x1="41113" y1="50096" x2="41113" y2="50096"/>
+                        <a14:foregroundMark x1="11035" y1="24283" x2="11035" y2="24283"/>
+                        <a14:foregroundMark x1="12207" y1="21989" x2="12207" y2="21989"/>
+                        <a14:foregroundMark x1="9766" y1="27342" x2="9766" y2="27342"/>
+                        <a14:foregroundMark x1="5859" y1="51816" x2="5859" y2="51816"/>
+                        <a14:foregroundMark x1="5957" y1="51052" x2="5957" y2="51052"/>
+                        <a14:foregroundMark x1="8008" y1="67113" x2="8008" y2="67113"/>
+                        <a14:foregroundMark x1="14648" y1="82792" x2="14355" y2="82409"/>
+                        <a14:foregroundMark x1="9961" y1="72658" x2="9375" y2="71319"/>
+                        <a14:foregroundMark x1="7031" y1="37859" x2="7031" y2="37859"/>
+                        <a14:foregroundMark x1="29980" y1="86424" x2="29980" y2="86424"/>
+                        <a14:backgroundMark x1="28906" y1="11855" x2="28906" y2="11855"/>
+                      </a14:backgroundRemoval>
+                    </a14:imgEffect>
+                  </a14:imgLayer>
+                </a14:imgProps>
+              </a:ext>
+            </a:extLst>
+          </a:blip>
+          <a:stretch>
+            <a:fillRect/>
+          </a:stretch>
+        </p:blipFill>
+        <p:spPr>
+          <a:xfrm>
+            <a:off x="1082040" y="3429000"/>
+            <a:ext cx="5165724" cy="2638353"/>
+          </a:xfrm>
+          <a:prstGeom prst="rect">
+            <a:avLst/>
+          </a:prstGeom>
+        </p:spPr>
+      </p:pic>
+    </p:spTree>
+    <p:extLst>
+      <p:ext uri="{BB962C8B-B14F-4D97-AF65-F5344CB8AC3E}">
+        <p14:creationId xmlns:p14="http://schemas.microsoft.com/office/powerpoint/2010/main" val="2422222930"/>
       </p:ext>
     </p:extLst>
   </p:cSld>

</xml_diff>